<commit_message>
sync: update skills repos, readme and charts
</commit_message>
<xml_diff>
--- a/skills/asklokesh--claudeskill-loki-mode/docs/loki-mode-presentation.pptx
+++ b/skills/asklokesh--claudeskill-loki-mode/docs/loki-mode-presentation.pptx
@@ -1803,6 +1803,10 @@
           </a:solidFill>
           <a:ln/>
         </p:spPr>
+        <p:txBody>
+          <a:bodyPr/>
+          <a:p/>
+        </p:txBody>
       </p:sp>
       <p:sp>
         <p:nvSpPr>
@@ -1823,6 +1827,10 @@
           </a:solidFill>
           <a:ln/>
         </p:spPr>
+        <p:txBody>
+          <a:bodyPr/>
+          <a:p/>
+        </p:txBody>
       </p:sp>
       <p:sp>
         <p:nvSpPr>
@@ -1906,7 +1914,7 @@
                 <a:ea typeface="Inter" pitchFamily="34" charset="-122"/>
                 <a:cs typeface="Inter" pitchFamily="34" charset="-120"/>
               </a:rPr>
-              <a:t>Loki Mode</a:t>
+              <a:t>Autonomi's Loki Mode</a:t>
             </a:r>
             <a:endParaRPr lang="en-US" sz="4353" dirty="0"/>
           </a:p>
@@ -1920,7 +1928,7 @@
         </p:nvSpPr>
         <p:spPr>
           <a:xfrm>
-            <a:off x="450056" y="2556318"/>
+            <a:off x="450056" y="3108960"/>
             <a:ext cx="3571875" cy="840088"/>
           </a:xfrm>
           <a:prstGeom prst="rect">
@@ -2029,7 +2037,7 @@
                 <a:ea typeface="JetBrains Mono" pitchFamily="34" charset="-122"/>
                 <a:cs typeface="JetBrains Mono" pitchFamily="34" charset="-120"/>
               </a:rPr>
-              <a:t> Powered by Autonomi (v6.6.0)</a:t>
+              <a:t> Powered by Autonomi (v7.26.0)</a:t>
             </a:r>
             <a:endParaRPr lang="en-US" sz="834" dirty="0"/>
           </a:p>
@@ -2061,6 +2069,10 @@
             <a:prstDash val="solid"/>
           </a:ln>
         </p:spPr>
+        <p:txBody>
+          <a:bodyPr/>
+          <a:p/>
+        </p:txBody>
       </p:sp>
       <p:pic>
         <p:nvPicPr>
@@ -2112,6 +2124,10 @@
             <a:prstDash val="solid"/>
           </a:ln>
         </p:spPr>
+        <p:txBody>
+          <a:bodyPr/>
+          <a:p/>
+        </p:txBody>
       </p:sp>
       <p:pic>
         <p:nvPicPr>
@@ -2163,6 +2179,10 @@
             <a:prstDash val="solid"/>
           </a:ln>
         </p:spPr>
+        <p:txBody>
+          <a:bodyPr/>
+          <a:p/>
+        </p:txBody>
       </p:sp>
       <p:pic>
         <p:nvPicPr>
@@ -2214,6 +2234,10 @@
             <a:prstDash val="solid"/>
           </a:ln>
         </p:spPr>
+        <p:txBody>
+          <a:bodyPr/>
+          <a:p/>
+        </p:txBody>
       </p:sp>
       <p:pic>
         <p:nvPicPr>
@@ -2265,6 +2289,10 @@
             <a:prstDash val="solid"/>
           </a:ln>
         </p:spPr>
+        <p:txBody>
+          <a:bodyPr/>
+          <a:p/>
+        </p:txBody>
       </p:sp>
       <p:pic>
         <p:nvPicPr>
@@ -2316,6 +2344,10 @@
             <a:prstDash val="solid"/>
           </a:ln>
         </p:spPr>
+        <p:txBody>
+          <a:bodyPr/>
+          <a:p/>
+        </p:txBody>
       </p:sp>
       <p:pic>
         <p:nvPicPr>
@@ -2365,6 +2397,10 @@
             <a:prstDash val="solid"/>
           </a:ln>
         </p:spPr>
+        <p:txBody>
+          <a:bodyPr/>
+          <a:p/>
+        </p:txBody>
       </p:sp>
       <p:pic>
         <p:nvPicPr>
@@ -2416,6 +2452,10 @@
             <a:prstDash val="solid"/>
           </a:ln>
         </p:spPr>
+        <p:txBody>
+          <a:bodyPr/>
+          <a:p/>
+        </p:txBody>
       </p:sp>
       <p:sp>
         <p:nvSpPr>
@@ -2455,7 +2495,7 @@
                 <a:ea typeface="JetBrains Mono" pitchFamily="34" charset="-122"/>
                 <a:cs typeface="JetBrains Mono" pitchFamily="34" charset="-120"/>
               </a:rPr>
-              <a:t>v6.6.0</a:t>
+              <a:t>v7.26.0</a:t>
             </a:r>
             <a:endParaRPr lang="en-US" sz="727" dirty="0"/>
           </a:p>
@@ -2714,6 +2754,10 @@
             <a:prstDash val="solid"/>
           </a:ln>
         </p:spPr>
+        <p:txBody>
+          <a:bodyPr/>
+          <a:p/>
+        </p:txBody>
       </p:sp>
       <p:pic>
         <p:nvPicPr>
@@ -2811,6 +2855,10 @@
             <a:prstDash val="solid"/>
           </a:ln>
         </p:spPr>
+        <p:txBody>
+          <a:bodyPr/>
+          <a:p/>
+        </p:txBody>
       </p:sp>
       <p:pic>
         <p:nvPicPr>
@@ -2908,6 +2956,10 @@
             <a:prstDash val="solid"/>
           </a:ln>
         </p:spPr>
+        <p:txBody>
+          <a:bodyPr/>
+          <a:p/>
+        </p:txBody>
       </p:sp>
       <p:pic>
         <p:nvPicPr>
@@ -3005,6 +3057,10 @@
             <a:prstDash val="solid"/>
           </a:ln>
         </p:spPr>
+        <p:txBody>
+          <a:bodyPr/>
+          <a:p/>
+        </p:txBody>
       </p:sp>
       <p:pic>
         <p:nvPicPr>
@@ -3745,7 +3801,7 @@
                 <a:ea typeface="Inter" pitchFamily="34" charset="-122"/>
                 <a:cs typeface="Inter" pitchFamily="34" charset="-120"/>
               </a:rPr>
-              <a:t>Loki Mode v6.6.0 is the most advanced autonomous framework for production software delivery. Join the Autonomi revolution and ship better code, faster.</a:t>
+              <a:t>Autonomi's Loki Mode v7.26.0 is the most advanced autonomous framework for production software delivery. Join the Autonomi revolution and ship better code, faster.</a:t>
             </a:r>
             <a:endParaRPr lang="en-US" sz="1269" dirty="0"/>
           </a:p>
@@ -3882,6 +3938,50 @@
                 <a:cs typeface="Inter" pitchFamily="34" charset="-120"/>
               </a:rPr>
               <a:t>github.com/asklokesh/loki-mode</a:t>
+            </a:r>
+            <a:endParaRPr lang="en-US" sz="885" dirty="0"/>
+          </a:p>
+        </p:txBody>
+      </p:sp>
+      <p:sp>
+        <p:nvSpPr>
+          <p:cNvPr id="17" name="Text 17"/>
+          <p:cNvSpPr/>
+          <p:nvPr/>
+        </p:nvSpPr>
+        <p:spPr>
+          <a:xfrm>
+            <a:off x="761228" y="4076916"/>
+            <a:ext cx="2094905" cy="155377"/>
+          </a:xfrm>
+          <a:prstGeom prst="rect">
+            <a:avLst/>
+          </a:prstGeom>
+          <a:noFill/>
+          <a:ln/>
+        </p:spPr>
+        <p:txBody>
+          <a:bodyPr wrap="none" lIns="0" tIns="0" rIns="0" bIns="0" rtlCol="0" anchor="t">
+            <a:spAutoFit/>
+          </a:bodyPr>
+          <a:lstStyle/>
+          <a:p>
+            <a:pPr algn="l" indent="0" marL="0">
+              <a:lnSpc>
+                <a:spcPts val="1200"/>
+              </a:lnSpc>
+              <a:buNone/>
+            </a:pPr>
+            <a:r>
+              <a:rPr lang="en-US" sz="885" b="1" dirty="0">
+                <a:solidFill>
+                  <a:srgbClr val="6366F1"/>
+                </a:solidFill>
+                <a:latin typeface="Inter" pitchFamily="34" charset="0"/>
+                <a:ea typeface="Inter" pitchFamily="34" charset="-122"/>
+                <a:cs typeface="Inter" pitchFamily="34" charset="-120"/>
+              </a:rPr>
+              <a:t>Autonomi Cloud - coming soon</a:t>
             </a:r>
             <a:endParaRPr lang="en-US" sz="885" dirty="0"/>
           </a:p>
@@ -3913,6 +4013,10 @@
             <a:prstDash val="solid"/>
           </a:ln>
         </p:spPr>
+        <p:txBody>
+          <a:bodyPr/>
+          <a:p/>
+        </p:txBody>
       </p:sp>
       <p:sp>
         <p:nvSpPr>
@@ -3935,6 +4039,10 @@
           </a:solidFill>
           <a:ln/>
         </p:spPr>
+        <p:txBody>
+          <a:bodyPr/>
+          <a:p/>
+        </p:txBody>
       </p:sp>
       <p:sp>
         <p:nvSpPr>
@@ -3955,6 +4063,10 @@
           </a:solidFill>
           <a:ln/>
         </p:spPr>
+        <p:txBody>
+          <a:bodyPr/>
+          <a:p/>
+        </p:txBody>
       </p:sp>
       <p:sp>
         <p:nvSpPr>
@@ -4205,7 +4317,7 @@
                 <a:ea typeface="JetBrains Mono" pitchFamily="34" charset="-122"/>
                 <a:cs typeface="JetBrains Mono" pitchFamily="34" charset="-120"/>
               </a:rPr>
-              <a:t> # 41 Agents | Concurrent Session #1</a:t>
+              <a:t> # 41 Agent Roles | Concurrent Session #1</a:t>
             </a:r>
             <a:pPr algn="l" indent="0" marL="0">
               <a:lnSpc>
@@ -4240,7 +4352,7 @@
                 <a:ea typeface="JetBrains Mono" pitchFamily="34" charset="-122"/>
                 <a:cs typeface="JetBrains Mono" pitchFamily="34" charset="-120"/>
               </a:rPr>
-              <a:t> # Quality Gates: v6.6.0 Ready</a:t>
+              <a:t> # Quality Gates: v7.26.0 Ready</a:t>
             </a:r>
             <a:endParaRPr lang="en-US" sz="727" dirty="0"/>
           </a:p>
@@ -4435,6 +4547,10 @@
             <a:prstDash val="solid"/>
           </a:ln>
         </p:spPr>
+        <p:txBody>
+          <a:bodyPr/>
+          <a:p/>
+        </p:txBody>
       </p:sp>
       <p:sp>
         <p:nvSpPr>
@@ -4508,6 +4624,10 @@
             <a:prstDash val="solid"/>
           </a:ln>
         </p:spPr>
+        <p:txBody>
+          <a:bodyPr/>
+          <a:p/>
+        </p:txBody>
       </p:sp>
       <p:sp>
         <p:nvSpPr>
@@ -4581,6 +4701,10 @@
             <a:prstDash val="solid"/>
           </a:ln>
         </p:spPr>
+        <p:txBody>
+          <a:bodyPr/>
+          <a:p/>
+        </p:txBody>
       </p:sp>
       <p:sp>
         <p:nvSpPr>
@@ -4722,6 +4846,10 @@
             <a:prstDash val="solid"/>
           </a:ln>
         </p:spPr>
+        <p:txBody>
+          <a:bodyPr/>
+          <a:p/>
+        </p:txBody>
       </p:sp>
       <p:sp>
         <p:nvSpPr>
@@ -4761,7 +4889,7 @@
                 <a:ea typeface="Inter" pitchFamily="34" charset="-122"/>
                 <a:cs typeface="Inter" pitchFamily="34" charset="-120"/>
               </a:rPr>
-              <a:t>Orchestrates 41 specialized AI agents across 8 swarms for full-lifecycle delivery.</a:t>
+              <a:t>Orchestrates 41 specialized agent roles across 8 domains for full-lifecycle delivery.</a:t>
             </a:r>
             <a:endParaRPr lang="en-US" sz="942" dirty="0"/>
           </a:p>
@@ -4795,6 +4923,10 @@
             <a:prstDash val="solid"/>
           </a:ln>
         </p:spPr>
+        <p:txBody>
+          <a:bodyPr/>
+          <a:p/>
+        </p:txBody>
       </p:sp>
       <p:sp>
         <p:nvSpPr>
@@ -4868,6 +5000,10 @@
             <a:prstDash val="solid"/>
           </a:ln>
         </p:spPr>
+        <p:txBody>
+          <a:bodyPr/>
+          <a:p/>
+        </p:txBody>
       </p:sp>
       <p:sp>
         <p:nvSpPr>
@@ -4932,6 +5068,10 @@
           </a:solidFill>
           <a:ln/>
         </p:spPr>
+        <p:txBody>
+          <a:bodyPr/>
+          <a:p/>
+        </p:txBody>
       </p:sp>
       <p:sp>
         <p:nvSpPr>
@@ -5143,7 +5283,7 @@
                 <a:ea typeface="Inter" pitchFamily="34" charset="-122"/>
                 <a:cs typeface="Inter" pitchFamily="34" charset="-120"/>
               </a:rPr>
-              <a:t>Framework Architecture: 8 Swarms</a:t>
+              <a:t>Framework Architecture: 8 Domains</a:t>
             </a:r>
             <a:endParaRPr lang="en-US" sz="2436" dirty="0"/>
           </a:p>
@@ -5187,7 +5327,7 @@
                 <a:ea typeface="Inter" pitchFamily="34" charset="-122"/>
                 <a:cs typeface="Inter" pitchFamily="34" charset="-120"/>
               </a:rPr>
-              <a:t>SWARM</a:t>
+              <a:t>DOMAIN</a:t>
             </a:r>
             <a:endParaRPr lang="en-US" sz="885" dirty="0"/>
           </a:p>
@@ -5377,6 +5517,10 @@
             <a:prstDash val="solid"/>
           </a:ln>
         </p:spPr>
+        <p:txBody>
+          <a:bodyPr/>
+          <a:p/>
+        </p:txBody>
       </p:sp>
       <p:sp>
         <p:nvSpPr>
@@ -5562,6 +5706,10 @@
             <a:prstDash val="solid"/>
           </a:ln>
         </p:spPr>
+        <p:txBody>
+          <a:bodyPr/>
+          <a:p/>
+        </p:txBody>
       </p:sp>
       <p:sp>
         <p:nvSpPr>
@@ -5747,6 +5895,10 @@
             <a:prstDash val="solid"/>
           </a:ln>
         </p:spPr>
+        <p:txBody>
+          <a:bodyPr/>
+          <a:p/>
+        </p:txBody>
       </p:sp>
       <p:sp>
         <p:nvSpPr>
@@ -5932,6 +6084,10 @@
             <a:prstDash val="solid"/>
           </a:ln>
         </p:spPr>
+        <p:txBody>
+          <a:bodyPr/>
+          <a:p/>
+        </p:txBody>
       </p:sp>
       <p:sp>
         <p:nvSpPr>
@@ -6117,6 +6273,10 @@
             <a:prstDash val="solid"/>
           </a:ln>
         </p:spPr>
+        <p:txBody>
+          <a:bodyPr/>
+          <a:p/>
+        </p:txBody>
       </p:sp>
       <p:sp>
         <p:nvSpPr>
@@ -6302,6 +6462,10 @@
             <a:prstDash val="solid"/>
           </a:ln>
         </p:spPr>
+        <p:txBody>
+          <a:bodyPr/>
+          <a:p/>
+        </p:txBody>
       </p:sp>
       <p:sp>
         <p:nvSpPr>
@@ -6487,6 +6651,10 @@
             <a:prstDash val="solid"/>
           </a:ln>
         </p:spPr>
+        <p:txBody>
+          <a:bodyPr/>
+          <a:p/>
+        </p:txBody>
       </p:sp>
       <p:sp>
         <p:nvSpPr>
@@ -6672,6 +6840,10 @@
             <a:prstDash val="solid"/>
           </a:ln>
         </p:spPr>
+        <p:txBody>
+          <a:bodyPr/>
+          <a:p/>
+        </p:txBody>
       </p:sp>
       <p:sp>
         <p:nvSpPr>
@@ -6782,6 +6954,10 @@
           </a:solidFill>
           <a:ln/>
         </p:spPr>
+        <p:txBody>
+          <a:bodyPr/>
+          <a:p/>
+        </p:txBody>
       </p:sp>
       <p:sp>
         <p:nvSpPr>
@@ -6855,6 +7031,10 @@
             <a:prstDash val="solid"/>
           </a:ln>
         </p:spPr>
+        <p:txBody>
+          <a:bodyPr/>
+          <a:p/>
+        </p:txBody>
       </p:sp>
       <p:sp>
         <p:nvSpPr>
@@ -7063,6 +7243,10 @@
             <a:prstDash val="solid"/>
           </a:ln>
         </p:spPr>
+        <p:txBody>
+          <a:bodyPr/>
+          <a:p/>
+        </p:txBody>
       </p:sp>
       <p:pic>
         <p:nvPicPr>
@@ -7226,6 +7410,10 @@
             <a:prstDash val="solid"/>
           </a:ln>
         </p:spPr>
+        <p:txBody>
+          <a:bodyPr/>
+          <a:p/>
+        </p:txBody>
       </p:sp>
       <p:pic>
         <p:nvPicPr>
@@ -7389,6 +7577,10 @@
             <a:prstDash val="solid"/>
           </a:ln>
         </p:spPr>
+        <p:txBody>
+          <a:bodyPr/>
+          <a:p/>
+        </p:txBody>
       </p:sp>
       <p:pic>
         <p:nvPicPr>
@@ -7552,6 +7744,10 @@
             <a:prstDash val="solid"/>
           </a:ln>
         </p:spPr>
+        <p:txBody>
+          <a:bodyPr/>
+          <a:p/>
+        </p:txBody>
       </p:sp>
       <p:sp>
         <p:nvSpPr>
@@ -7786,6 +7982,10 @@
             <a:prstDash val="solid"/>
           </a:ln>
         </p:spPr>
+        <p:txBody>
+          <a:bodyPr/>
+          <a:p/>
+        </p:txBody>
       </p:sp>
       <p:pic>
         <p:nvPicPr>
@@ -8108,6 +8308,10 @@
             <a:prstDash val="solid"/>
           </a:ln>
         </p:spPr>
+        <p:txBody>
+          <a:bodyPr/>
+          <a:p/>
+        </p:txBody>
       </p:sp>
       <p:sp>
         <p:nvSpPr>
@@ -8225,6 +8429,10 @@
             <a:prstDash val="solid"/>
           </a:ln>
         </p:spPr>
+        <p:txBody>
+          <a:bodyPr/>
+          <a:p/>
+        </p:txBody>
       </p:sp>
       <p:sp>
         <p:nvSpPr>
@@ -8342,6 +8550,10 @@
             <a:prstDash val="solid"/>
           </a:ln>
         </p:spPr>
+        <p:txBody>
+          <a:bodyPr/>
+          <a:p/>
+        </p:txBody>
       </p:sp>
       <p:sp>
         <p:nvSpPr>
@@ -8459,6 +8671,10 @@
             <a:prstDash val="solid"/>
           </a:ln>
         </p:spPr>
+        <p:txBody>
+          <a:bodyPr/>
+          <a:p/>
+        </p:txBody>
       </p:sp>
       <p:sp>
         <p:nvSpPr>
@@ -8576,6 +8792,10 @@
             <a:prstDash val="solid"/>
           </a:ln>
         </p:spPr>
+        <p:txBody>
+          <a:bodyPr/>
+          <a:p/>
+        </p:txBody>
       </p:sp>
       <p:sp>
         <p:nvSpPr>
@@ -8693,6 +8913,10 @@
             <a:prstDash val="solid"/>
           </a:ln>
         </p:spPr>
+        <p:txBody>
+          <a:bodyPr/>
+          <a:p/>
+        </p:txBody>
       </p:sp>
       <p:sp>
         <p:nvSpPr>
@@ -8810,6 +9034,10 @@
             <a:prstDash val="solid"/>
           </a:ln>
         </p:spPr>
+        <p:txBody>
+          <a:bodyPr/>
+          <a:p/>
+        </p:txBody>
       </p:sp>
       <p:sp>
         <p:nvSpPr>
@@ -8927,6 +9155,10 @@
             <a:prstDash val="solid"/>
           </a:ln>
         </p:spPr>
+        <p:txBody>
+          <a:bodyPr/>
+          <a:p/>
+        </p:txBody>
       </p:sp>
       <p:sp>
         <p:nvSpPr>
@@ -9044,6 +9276,10 @@
             <a:prstDash val="solid"/>
           </a:ln>
         </p:spPr>
+        <p:txBody>
+          <a:bodyPr/>
+          <a:p/>
+        </p:txBody>
       </p:sp>
       <p:sp>
         <p:nvSpPr>
@@ -9159,6 +9395,10 @@
             <a:prstDash val="solid"/>
           </a:ln>
         </p:spPr>
+        <p:txBody>
+          <a:bodyPr/>
+          <a:p/>
+        </p:txBody>
       </p:sp>
       <p:sp>
         <p:nvSpPr>
@@ -9330,7 +9570,7 @@
                 <a:ea typeface="JetBrains Mono" pitchFamily="34" charset="-122"/>
                 <a:cs typeface="JetBrains Mono" pitchFamily="34" charset="-120"/>
               </a:rPr>
-              <a:t>SWE-bench: 299/300 Patches</a:t>
+              <a:t/>
             </a:r>
             <a:pPr algn="ctr" indent="0" marL="0">
               <a:lnSpc>
@@ -9492,6 +9732,10 @@
             <a:prstDash val="solid"/>
           </a:ln>
         </p:spPr>
+        <p:txBody>
+          <a:bodyPr/>
+          <a:p/>
+        </p:txBody>
       </p:sp>
       <p:pic>
         <p:nvPicPr>
@@ -9555,7 +9799,7 @@
                 <a:ea typeface="Inter" pitchFamily="34" charset="-122"/>
                 <a:cs typeface="Inter" pitchFamily="34" charset="-120"/>
               </a:rPr>
-              <a:t>5-PROVIDER ERA</a:t>
+              <a:t>PROVIDER SUPPORT</a:t>
             </a:r>
             <a:endParaRPr lang="en-US" sz="1193" dirty="0"/>
           </a:p>
@@ -9640,7 +9884,7 @@
                 <a:ea typeface="Inter" pitchFamily="34" charset="-122"/>
                 <a:cs typeface="Inter" pitchFamily="34" charset="-120"/>
               </a:rPr>
-              <a:t>: Full multi-agent </a:t>
+              <a:t>: Tier 1 primary, </a:t>
             </a:r>
             <a:pPr algn="l" indent="0" marL="0">
               <a:lnSpc>
@@ -9657,7 +9901,7 @@
                 <a:ea typeface="Inter" pitchFamily="34" charset="-122"/>
                 <a:cs typeface="Inter" pitchFamily="34" charset="-120"/>
               </a:rPr>
-              <a:t>parallel support</a:t>
+              <a:t>E2E-verified</a:t>
             </a:r>
             <a:endParaRPr lang="en-US" sz="784" dirty="0"/>
           </a:p>
@@ -9725,7 +9969,7 @@
                 <a:ea typeface="JetBrains Mono" pitchFamily="34" charset="-122"/>
                 <a:cs typeface="JetBrains Mono" pitchFamily="34" charset="-120"/>
               </a:rPr>
-              <a:t>Cline CLI</a:t>
+              <a:t>Cline</a:t>
             </a:r>
             <a:pPr algn="l" indent="0" marL="0">
               <a:lnSpc>
@@ -9742,7 +9986,7 @@
                 <a:ea typeface="Inter" pitchFamily="34" charset="-122"/>
                 <a:cs typeface="Inter" pitchFamily="34" charset="-120"/>
               </a:rPr>
-              <a:t>: Near-full </a:t>
+              <a:t>: Experimental </a:t>
             </a:r>
             <a:pPr algn="l" indent="0" marL="0">
               <a:lnSpc>
@@ -9759,7 +10003,7 @@
                 <a:ea typeface="Inter" pitchFamily="34" charset="-122"/>
                 <a:cs typeface="Inter" pitchFamily="34" charset="-120"/>
               </a:rPr>
-              <a:t>subagent/MCP support</a:t>
+              <a:t>provider</a:t>
             </a:r>
             <a:endParaRPr lang="en-US" sz="784" dirty="0"/>
           </a:p>
@@ -9844,7 +10088,7 @@
                 <a:ea typeface="Inter" pitchFamily="34" charset="-122"/>
                 <a:cs typeface="Inter" pitchFamily="34" charset="-120"/>
               </a:rPr>
-              <a:t>: 18+ model provider </a:t>
+              <a:t>: Experimental, </a:t>
             </a:r>
             <a:pPr algn="l" indent="0" marL="0">
               <a:lnSpc>
@@ -9861,7 +10105,7 @@
                 <a:ea typeface="Inter" pitchFamily="34" charset="-122"/>
                 <a:cs typeface="Inter" pitchFamily="34" charset="-120"/>
               </a:rPr>
-              <a:t>support</a:t>
+              <a:t>18+ models</a:t>
             </a:r>
             <a:endParaRPr lang="en-US" sz="784" dirty="0"/>
           </a:p>
@@ -9929,7 +10173,7 @@
                 <a:ea typeface="JetBrains Mono" pitchFamily="34" charset="-122"/>
                 <a:cs typeface="JetBrains Mono" pitchFamily="34" charset="-120"/>
               </a:rPr>
-              <a:t>Codex/Gemini</a:t>
+              <a:t>Codex</a:t>
             </a:r>
             <a:pPr algn="l" indent="0" marL="0">
               <a:lnSpc>
@@ -9946,7 +10190,7 @@
                 <a:ea typeface="Inter" pitchFamily="34" charset="-122"/>
                 <a:cs typeface="Inter" pitchFamily="34" charset="-120"/>
               </a:rPr>
-              <a:t>: Sequential </a:t>
+              <a:t>: Experimental </a:t>
             </a:r>
             <a:pPr algn="l" indent="0" marL="0">
               <a:lnSpc>
@@ -9963,7 +10207,7 @@
                 <a:ea typeface="Inter" pitchFamily="34" charset="-122"/>
                 <a:cs typeface="Inter" pitchFamily="34" charset="-120"/>
               </a:rPr>
-              <a:t>execution</a:t>
+              <a:t>provider</a:t>
             </a:r>
             <a:endParaRPr lang="en-US" sz="784" dirty="0"/>
           </a:p>
@@ -9997,6 +10241,10 @@
             <a:prstDash val="solid"/>
           </a:ln>
         </p:spPr>
+        <p:txBody>
+          <a:bodyPr/>
+          <a:p/>
+        </p:txBody>
       </p:sp>
       <p:pic>
         <p:nvPicPr>
@@ -10468,6 +10716,10 @@
             <a:prstDash val="solid"/>
           </a:ln>
         </p:spPr>
+        <p:txBody>
+          <a:bodyPr/>
+          <a:p/>
+        </p:txBody>
       </p:sp>
       <p:pic>
         <p:nvPicPr>
@@ -11015,6 +11267,10 @@
             <a:prstDash val="solid"/>
           </a:ln>
         </p:spPr>
+        <p:txBody>
+          <a:bodyPr/>
+          <a:p/>
+        </p:txBody>
       </p:sp>
       <p:pic>
         <p:nvPicPr>
@@ -11418,6 +11674,10 @@
             <a:prstDash val="solid"/>
           </a:ln>
         </p:spPr>
+        <p:txBody>
+          <a:bodyPr/>
+          <a:p/>
+        </p:txBody>
       </p:sp>
       <p:pic>
         <p:nvPicPr>
@@ -11821,6 +12081,10 @@
             <a:prstDash val="solid"/>
           </a:ln>
         </p:spPr>
+        <p:txBody>
+          <a:bodyPr/>
+          <a:p/>
+        </p:txBody>
       </p:sp>
       <p:pic>
         <p:nvPicPr>
@@ -12190,7 +12454,7 @@
                 <a:ea typeface="Inter" pitchFamily="34" charset="-122"/>
                 <a:cs typeface="Inter" pitchFamily="34" charset="-120"/>
               </a:rPr>
-              <a:t>WebSocket monitoring</a:t>
+              <a:t>WebSocket monitoring + Live App Preview</a:t>
             </a:r>
             <a:endParaRPr lang="en-US" sz="784" dirty="0"/>
           </a:p>
@@ -12315,6 +12579,10 @@
             <a:prstDash val="solid"/>
           </a:ln>
         </p:spPr>
+        <p:txBody>
+          <a:bodyPr/>
+          <a:p/>
+        </p:txBody>
       </p:sp>
       <p:pic>
         <p:nvPicPr>
@@ -12412,6 +12680,10 @@
             <a:prstDash val="solid"/>
           </a:ln>
         </p:spPr>
+        <p:txBody>
+          <a:bodyPr/>
+          <a:p/>
+        </p:txBody>
       </p:sp>
       <p:pic>
         <p:nvPicPr>
@@ -12553,6 +12825,10 @@
             <a:prstDash val="solid"/>
           </a:ln>
         </p:spPr>
+        <p:txBody>
+          <a:bodyPr/>
+          <a:p/>
+        </p:txBody>
       </p:sp>
       <p:sp>
         <p:nvSpPr>
@@ -12626,6 +12902,10 @@
             <a:prstDash val="solid"/>
           </a:ln>
         </p:spPr>
+        <p:txBody>
+          <a:bodyPr/>
+          <a:p/>
+        </p:txBody>
       </p:sp>
       <p:sp>
         <p:nvSpPr>
@@ -12699,6 +12979,10 @@
             <a:prstDash val="solid"/>
           </a:ln>
         </p:spPr>
+        <p:txBody>
+          <a:bodyPr/>
+          <a:p/>
+        </p:txBody>
       </p:sp>
       <p:sp>
         <p:nvSpPr>
@@ -12840,6 +13124,10 @@
             <a:prstDash val="solid"/>
           </a:ln>
         </p:spPr>
+        <p:txBody>
+          <a:bodyPr/>
+          <a:p/>
+        </p:txBody>
       </p:sp>
       <p:pic>
         <p:nvPicPr>
@@ -12981,6 +13269,10 @@
             <a:prstDash val="solid"/>
           </a:ln>
         </p:spPr>
+        <p:txBody>
+          <a:bodyPr/>
+          <a:p/>
+        </p:txBody>
       </p:sp>
       <p:sp>
         <p:nvSpPr>
@@ -13054,6 +13346,10 @@
             <a:prstDash val="solid"/>
           </a:ln>
         </p:spPr>
+        <p:txBody>
+          <a:bodyPr/>
+          <a:p/>
+        </p:txBody>
       </p:sp>
       <p:sp>
         <p:nvSpPr>
@@ -13127,6 +13423,10 @@
             <a:prstDash val="solid"/>
           </a:ln>
         </p:spPr>
+        <p:txBody>
+          <a:bodyPr/>
+          <a:p/>
+        </p:txBody>
       </p:sp>
       <p:sp>
         <p:nvSpPr>
@@ -13268,6 +13568,10 @@
             <a:prstDash val="solid"/>
           </a:ln>
         </p:spPr>
+        <p:txBody>
+          <a:bodyPr/>
+          <a:p/>
+        </p:txBody>
       </p:sp>
       <p:pic>
         <p:nvPicPr>
@@ -13409,6 +13713,10 @@
             <a:prstDash val="solid"/>
           </a:ln>
         </p:spPr>
+        <p:txBody>
+          <a:bodyPr/>
+          <a:p/>
+        </p:txBody>
       </p:sp>
       <p:sp>
         <p:nvSpPr>
@@ -13482,6 +13790,10 @@
             <a:prstDash val="solid"/>
           </a:ln>
         </p:spPr>
+        <p:txBody>
+          <a:bodyPr/>
+          <a:p/>
+        </p:txBody>
       </p:sp>
       <p:sp>
         <p:nvSpPr>
@@ -13555,6 +13867,10 @@
             <a:prstDash val="solid"/>
           </a:ln>
         </p:spPr>
+        <p:txBody>
+          <a:bodyPr/>
+          <a:p/>
+        </p:txBody>
       </p:sp>
       <p:sp>
         <p:nvSpPr>
@@ -13696,6 +14012,10 @@
             <a:prstDash val="solid"/>
           </a:ln>
         </p:spPr>
+        <p:txBody>
+          <a:bodyPr/>
+          <a:p/>
+        </p:txBody>
       </p:sp>
       <p:pic>
         <p:nvPicPr>
@@ -13837,6 +14157,10 @@
             <a:prstDash val="solid"/>
           </a:ln>
         </p:spPr>
+        <p:txBody>
+          <a:bodyPr/>
+          <a:p/>
+        </p:txBody>
       </p:sp>
       <p:sp>
         <p:nvSpPr>
@@ -13910,6 +14234,10 @@
             <a:prstDash val="solid"/>
           </a:ln>
         </p:spPr>
+        <p:txBody>
+          <a:bodyPr/>
+          <a:p/>
+        </p:txBody>
       </p:sp>
       <p:sp>
         <p:nvSpPr>
@@ -13983,6 +14311,10 @@
             <a:prstDash val="solid"/>
           </a:ln>
         </p:spPr>
+        <p:txBody>
+          <a:bodyPr/>
+          <a:p/>
+        </p:txBody>
       </p:sp>
       <p:sp>
         <p:nvSpPr>
@@ -14183,7 +14515,7 @@
                 <a:ea typeface="Inter" pitchFamily="34" charset="-122"/>
                 <a:cs typeface="Inter" pitchFamily="34" charset="-120"/>
               </a:rPr>
-              <a:t>Why Loki Mode is Better (v6.6.0)</a:t>
+              <a:t>Why Loki Mode is Better (v7.26.0)</a:t>
             </a:r>
             <a:endParaRPr lang="en-US" sz="2436" dirty="0"/>
           </a:p>
@@ -14252,6 +14584,10 @@
           </a:solidFill>
           <a:ln/>
         </p:spPr>
+        <p:txBody>
+          <a:bodyPr/>
+          <a:p/>
+        </p:txBody>
       </p:sp>
       <p:sp>
         <p:nvSpPr>
@@ -14272,6 +14608,10 @@
           </a:solidFill>
           <a:ln/>
         </p:spPr>
+        <p:txBody>
+          <a:bodyPr/>
+          <a:p/>
+        </p:txBody>
       </p:sp>
       <p:sp>
         <p:nvSpPr>
@@ -14426,6 +14766,10 @@
           </a:solidFill>
           <a:ln/>
         </p:spPr>
+        <p:txBody>
+          <a:bodyPr/>
+          <a:p/>
+        </p:txBody>
       </p:sp>
       <p:sp>
         <p:nvSpPr>
@@ -14446,6 +14790,10 @@
           </a:solidFill>
           <a:ln/>
         </p:spPr>
+        <p:txBody>
+          <a:bodyPr/>
+          <a:p/>
+        </p:txBody>
       </p:sp>
       <p:sp>
         <p:nvSpPr>
@@ -14466,6 +14814,10 @@
           </a:solidFill>
           <a:ln/>
         </p:spPr>
+        <p:txBody>
+          <a:bodyPr/>
+          <a:p/>
+        </p:txBody>
       </p:sp>
       <p:sp>
         <p:nvSpPr>
@@ -14486,6 +14838,10 @@
           </a:solidFill>
           <a:ln/>
         </p:spPr>
+        <p:txBody>
+          <a:bodyPr/>
+          <a:p/>
+        </p:txBody>
       </p:sp>
       <p:pic>
         <p:nvPicPr>
@@ -14690,6 +15046,10 @@
           </a:solidFill>
           <a:ln/>
         </p:spPr>
+        <p:txBody>
+          <a:bodyPr/>
+          <a:p/>
+        </p:txBody>
       </p:sp>
       <p:sp>
         <p:nvSpPr>
@@ -14710,6 +15070,10 @@
           </a:solidFill>
           <a:ln/>
         </p:spPr>
+        <p:txBody>
+          <a:bodyPr/>
+          <a:p/>
+        </p:txBody>
       </p:sp>
       <p:sp>
         <p:nvSpPr>
@@ -14730,6 +15094,10 @@
           </a:solidFill>
           <a:ln/>
         </p:spPr>
+        <p:txBody>
+          <a:bodyPr/>
+          <a:p/>
+        </p:txBody>
       </p:sp>
       <p:sp>
         <p:nvSpPr>
@@ -14750,6 +15118,10 @@
           </a:solidFill>
           <a:ln/>
         </p:spPr>
+        <p:txBody>
+          <a:bodyPr/>
+          <a:p/>
+        </p:txBody>
       </p:sp>
       <p:pic>
         <p:nvPicPr>
@@ -14813,7 +15185,7 @@
                 <a:ea typeface="Inter" pitchFamily="34" charset="-122"/>
                 <a:cs typeface="Inter" pitchFamily="34" charset="-120"/>
               </a:rPr>
-              <a:t>41 Agents + Recursive Sub-Planning</a:t>
+              <a:t>41 Agent Roles + Recursive Sub-Planning</a:t>
             </a:r>
             <a:endParaRPr lang="en-US" sz="885" dirty="0"/>
           </a:p>
@@ -14954,6 +15326,10 @@
           </a:solidFill>
           <a:ln/>
         </p:spPr>
+        <p:txBody>
+          <a:bodyPr/>
+          <a:p/>
+        </p:txBody>
       </p:sp>
       <p:sp>
         <p:nvSpPr>
@@ -14974,6 +15350,10 @@
           </a:solidFill>
           <a:ln/>
         </p:spPr>
+        <p:txBody>
+          <a:bodyPr/>
+          <a:p/>
+        </p:txBody>
       </p:sp>
       <p:sp>
         <p:nvSpPr>
@@ -14994,6 +15374,10 @@
           </a:solidFill>
           <a:ln/>
         </p:spPr>
+        <p:txBody>
+          <a:bodyPr/>
+          <a:p/>
+        </p:txBody>
       </p:sp>
       <p:sp>
         <p:nvSpPr>
@@ -15014,6 +15398,10 @@
           </a:solidFill>
           <a:ln/>
         </p:spPr>
+        <p:txBody>
+          <a:bodyPr/>
+          <a:p/>
+        </p:txBody>
       </p:sp>
       <p:pic>
         <p:nvPicPr>
@@ -15218,6 +15606,10 @@
           </a:solidFill>
           <a:ln/>
         </p:spPr>
+        <p:txBody>
+          <a:bodyPr/>
+          <a:p/>
+        </p:txBody>
       </p:sp>
       <p:sp>
         <p:nvSpPr>
@@ -15238,6 +15630,10 @@
           </a:solidFill>
           <a:ln/>
         </p:spPr>
+        <p:txBody>
+          <a:bodyPr/>
+          <a:p/>
+        </p:txBody>
       </p:sp>
       <p:sp>
         <p:nvSpPr>
@@ -15258,6 +15654,10 @@
           </a:solidFill>
           <a:ln/>
         </p:spPr>
+        <p:txBody>
+          <a:bodyPr/>
+          <a:p/>
+        </p:txBody>
       </p:sp>
       <p:sp>
         <p:nvSpPr>
@@ -15278,6 +15678,10 @@
           </a:solidFill>
           <a:ln/>
         </p:spPr>
+        <p:txBody>
+          <a:bodyPr/>
+          <a:p/>
+        </p:txBody>
       </p:sp>
       <p:pic>
         <p:nvPicPr>
@@ -15482,6 +15886,10 @@
           </a:solidFill>
           <a:ln/>
         </p:spPr>
+        <p:txBody>
+          <a:bodyPr/>
+          <a:p/>
+        </p:txBody>
       </p:sp>
       <p:sp>
         <p:nvSpPr>
@@ -15502,6 +15910,10 @@
           </a:solidFill>
           <a:ln/>
         </p:spPr>
+        <p:txBody>
+          <a:bodyPr/>
+          <a:p/>
+        </p:txBody>
       </p:sp>
       <p:sp>
         <p:nvSpPr>
@@ -15522,6 +15934,10 @@
           </a:solidFill>
           <a:ln/>
         </p:spPr>
+        <p:txBody>
+          <a:bodyPr/>
+          <a:p/>
+        </p:txBody>
       </p:sp>
       <p:sp>
         <p:nvSpPr>
@@ -15542,6 +15958,10 @@
           </a:solidFill>
           <a:ln/>
         </p:spPr>
+        <p:txBody>
+          <a:bodyPr/>
+          <a:p/>
+        </p:txBody>
       </p:sp>
       <p:pic>
         <p:nvPicPr>

</xml_diff>